<commit_message>
Update slides and starter files for day 4-5
</commit_message>
<xml_diff>
--- a/day4/Day4_MiniZinc_Slides .pptx
+++ b/day4/Day4_MiniZinc_Slides .pptx
@@ -9164,45 +9164,6 @@
       </p:sp>
       <p:sp>
         <p:nvSpPr>
-          <p:cNvPr id="12" name="Text 10"/>
-          <p:cNvSpPr/>
-          <p:nvPr/>
-        </p:nvSpPr>
-        <p:spPr>
-          <a:xfrm>
-            <a:off x="3749040" y="2395728"/>
-            <a:ext cx="4937760" cy="411480"/>
-          </a:xfrm>
-          <a:prstGeom prst="rect">
-            <a:avLst/>
-          </a:prstGeom>
-          <a:noFill/>
-          <a:ln/>
-        </p:spPr>
-        <p:txBody>
-          <a:bodyPr wrap="square" rtlCol="0" anchor="ctr"/>
-          <a:lstStyle/>
-          <a:p>
-            <a:pPr marL="0" indent="0">
-              <a:buNone/>
-            </a:pPr>
-            <a:r>
-              <a:rPr lang="en-US" sz="1050" dirty="0">
-                <a:solidFill>
-                  <a:srgbClr val="2D3748"/>
-                </a:solidFill>
-                <a:latin typeface="Consolas" pitchFamily="34" charset="0"/>
-                <a:ea typeface="Consolas" pitchFamily="34" charset="-122"/>
-                <a:cs typeface="Consolas" pitchFamily="34" charset="-120"/>
-              </a:rPr>
-              <a:t>forall(d)(sum(e)(roster[e,d]=M) &gt;= req_M /\ ...)</a:t>
-            </a:r>
-            <a:endParaRPr lang="en-US" sz="1050" dirty="0"/>
-          </a:p>
-        </p:txBody>
-      </p:sp>
-      <p:sp>
-        <p:nvSpPr>
           <p:cNvPr id="13" name="Shape 11"/>
           <p:cNvSpPr/>
           <p:nvPr/>
@@ -9335,45 +9296,6 @@
       </p:sp>
       <p:sp>
         <p:nvSpPr>
-          <p:cNvPr id="17" name="Text 15"/>
-          <p:cNvSpPr/>
-          <p:nvPr/>
-        </p:nvSpPr>
-        <p:spPr>
-          <a:xfrm>
-            <a:off x="3749040" y="2862072"/>
-            <a:ext cx="4937760" cy="411480"/>
-          </a:xfrm>
-          <a:prstGeom prst="rect">
-            <a:avLst/>
-          </a:prstGeom>
-          <a:noFill/>
-          <a:ln/>
-        </p:spPr>
-        <p:txBody>
-          <a:bodyPr wrap="square" rtlCol="0" anchor="ctr"/>
-          <a:lstStyle/>
-          <a:p>
-            <a:pPr marL="0" indent="0">
-              <a:buNone/>
-            </a:pPr>
-            <a:r>
-              <a:rPr lang="en-US" sz="1050" dirty="0">
-                <a:solidFill>
-                  <a:srgbClr val="2D3748"/>
-                </a:solidFill>
-                <a:latin typeface="Consolas" pitchFamily="34" charset="0"/>
-                <a:ea typeface="Consolas" pitchFamily="34" charset="-122"/>
-                <a:cs typeface="Consolas" pitchFamily="34" charset="-120"/>
-              </a:rPr>
-              <a:t>roster[e,d]=N -&gt; roster[e,d+1]=O  (ทุก e, d &lt; 14)</a:t>
-            </a:r>
-            <a:endParaRPr lang="en-US" sz="1050" dirty="0"/>
-          </a:p>
-        </p:txBody>
-      </p:sp>
-      <p:sp>
-        <p:nvSpPr>
           <p:cNvPr id="18" name="Shape 16"/>
           <p:cNvSpPr/>
           <p:nvPr/>
@@ -9506,45 +9428,6 @@
       </p:sp>
       <p:sp>
         <p:nvSpPr>
-          <p:cNvPr id="22" name="Text 20"/>
-          <p:cNvSpPr/>
-          <p:nvPr/>
-        </p:nvSpPr>
-        <p:spPr>
-          <a:xfrm>
-            <a:off x="3749040" y="3328416"/>
-            <a:ext cx="4937760" cy="411480"/>
-          </a:xfrm>
-          <a:prstGeom prst="rect">
-            <a:avLst/>
-          </a:prstGeom>
-          <a:noFill/>
-          <a:ln/>
-        </p:spPr>
-        <p:txBody>
-          <a:bodyPr wrap="square" rtlCol="0" anchor="ctr"/>
-          <a:lstStyle/>
-          <a:p>
-            <a:pPr marL="0" indent="0">
-              <a:buNone/>
-            </a:pPr>
-            <a:r>
-              <a:rPr lang="en-US" sz="1050" dirty="0">
-                <a:solidFill>
-                  <a:srgbClr val="2D3748"/>
-                </a:solidFill>
-                <a:latin typeface="Consolas" pitchFamily="34" charset="0"/>
-                <a:ea typeface="Consolas" pitchFamily="34" charset="-122"/>
-                <a:cs typeface="Consolas" pitchFamily="34" charset="-120"/>
-              </a:rPr>
-              <a:t>forall(e,d0)(sum(d in d0..d0+6)(roster[e,d]!=O) &lt;= 6)</a:t>
-            </a:r>
-            <a:endParaRPr lang="en-US" sz="1050" dirty="0"/>
-          </a:p>
-        </p:txBody>
-      </p:sp>
-      <p:sp>
-        <p:nvSpPr>
           <p:cNvPr id="23" name="Shape 21"/>
           <p:cNvSpPr/>
           <p:nvPr/>
@@ -9672,45 +9555,6 @@
               <a:t>solve minimize total_nights: </a:t>
             </a:r>
             <a:endParaRPr lang="en-US" sz="1150" dirty="0"/>
-          </a:p>
-        </p:txBody>
-      </p:sp>
-      <p:sp>
-        <p:nvSpPr>
-          <p:cNvPr id="27" name="Text 25"/>
-          <p:cNvSpPr/>
-          <p:nvPr/>
-        </p:nvSpPr>
-        <p:spPr>
-          <a:xfrm>
-            <a:off x="3749040" y="3794760"/>
-            <a:ext cx="4937760" cy="411480"/>
-          </a:xfrm>
-          <a:prstGeom prst="rect">
-            <a:avLst/>
-          </a:prstGeom>
-          <a:noFill/>
-          <a:ln/>
-        </p:spPr>
-        <p:txBody>
-          <a:bodyPr wrap="square" rtlCol="0" anchor="ctr"/>
-          <a:lstStyle/>
-          <a:p>
-            <a:pPr marL="0" indent="0">
-              <a:buNone/>
-            </a:pPr>
-            <a:r>
-              <a:rPr lang="en-US" sz="1050" dirty="0">
-                <a:solidFill>
-                  <a:srgbClr val="2D3748"/>
-                </a:solidFill>
-                <a:latin typeface="Consolas" pitchFamily="34" charset="0"/>
-                <a:ea typeface="Consolas" pitchFamily="34" charset="-122"/>
-                <a:cs typeface="Consolas" pitchFamily="34" charset="-120"/>
-              </a:rPr>
-              <a:t>เปลี่ยน solve satisfy → minimize แล้วรัน</a:t>
-            </a:r>
-            <a:endParaRPr lang="en-US" sz="1050" dirty="0"/>
           </a:p>
         </p:txBody>
       </p:sp>
@@ -21831,45 +21675,6 @@
       </p:sp>
       <p:sp>
         <p:nvSpPr>
-          <p:cNvPr id="12" name="Text 10"/>
-          <p:cNvSpPr/>
-          <p:nvPr/>
-        </p:nvSpPr>
-        <p:spPr>
-          <a:xfrm>
-            <a:off x="3931920" y="2304288"/>
-            <a:ext cx="4754880" cy="420624"/>
-          </a:xfrm>
-          <a:prstGeom prst="rect">
-            <a:avLst/>
-          </a:prstGeom>
-          <a:noFill/>
-          <a:ln/>
-        </p:spPr>
-        <p:txBody>
-          <a:bodyPr wrap="square" rtlCol="0" anchor="ctr"/>
-          <a:lstStyle/>
-          <a:p>
-            <a:pPr marL="0" indent="0">
-              <a:buNone/>
-            </a:pPr>
-            <a:r>
-              <a:rPr lang="en-US" sz="1050" dirty="0">
-                <a:solidFill>
-                  <a:srgbClr val="2D3748"/>
-                </a:solidFill>
-                <a:latin typeface="Consolas" pitchFamily="34" charset="0"/>
-                <a:ea typeface="Consolas" pitchFamily="34" charset="-122"/>
-                <a:cs typeface="Consolas" pitchFamily="34" charset="-120"/>
-              </a:rPr>
-              <a:t>forall(j,t)( dur[j,t,machine[j,t]] &gt; 0 )</a:t>
-            </a:r>
-            <a:endParaRPr lang="en-US" sz="1050" dirty="0"/>
-          </a:p>
-        </p:txBody>
-      </p:sp>
-      <p:sp>
-        <p:nvSpPr>
           <p:cNvPr id="13" name="Shape 11"/>
           <p:cNvSpPr/>
           <p:nvPr/>
@@ -22002,45 +21807,6 @@
       </p:sp>
       <p:sp>
         <p:nvSpPr>
-          <p:cNvPr id="17" name="Text 15"/>
-          <p:cNvSpPr/>
-          <p:nvPr/>
-        </p:nvSpPr>
-        <p:spPr>
-          <a:xfrm>
-            <a:off x="3931920" y="2779776"/>
-            <a:ext cx="4754880" cy="420624"/>
-          </a:xfrm>
-          <a:prstGeom prst="rect">
-            <a:avLst/>
-          </a:prstGeom>
-          <a:noFill/>
-          <a:ln/>
-        </p:spPr>
-        <p:txBody>
-          <a:bodyPr wrap="square" rtlCol="0" anchor="ctr"/>
-          <a:lstStyle/>
-          <a:p>
-            <a:pPr marL="0" indent="0">
-              <a:buNone/>
-            </a:pPr>
-            <a:r>
-              <a:rPr lang="en-US" sz="1050" dirty="0">
-                <a:solidFill>
-                  <a:srgbClr val="2D3748"/>
-                </a:solidFill>
-                <a:latin typeface="Consolas" pitchFamily="34" charset="0"/>
-                <a:ea typeface="Consolas" pitchFamily="34" charset="-122"/>
-                <a:cs typeface="Consolas" pitchFamily="34" charset="-120"/>
-              </a:rPr>
-              <a:t>start[j,t]+dur[j,t,machine[j,t]] &lt;= start[j,enum_next(TASK,t)]</a:t>
-            </a:r>
-            <a:endParaRPr lang="en-US" sz="1050" dirty="0"/>
-          </a:p>
-        </p:txBody>
-      </p:sp>
-      <p:sp>
-        <p:nvSpPr>
           <p:cNvPr id="18" name="Shape 16"/>
           <p:cNvSpPr/>
           <p:nvPr/>
@@ -22173,45 +21939,6 @@
       </p:sp>
       <p:sp>
         <p:nvSpPr>
-          <p:cNvPr id="22" name="Text 20"/>
-          <p:cNvSpPr/>
-          <p:nvPr/>
-        </p:nvSpPr>
-        <p:spPr>
-          <a:xfrm>
-            <a:off x="3931920" y="3255264"/>
-            <a:ext cx="4754880" cy="420624"/>
-          </a:xfrm>
-          <a:prstGeom prst="rect">
-            <a:avLst/>
-          </a:prstGeom>
-          <a:noFill/>
-          <a:ln/>
-        </p:spPr>
-        <p:txBody>
-          <a:bodyPr wrap="square" rtlCol="0" anchor="ctr"/>
-          <a:lstStyle/>
-          <a:p>
-            <a:pPr marL="0" indent="0">
-              <a:buNone/>
-            </a:pPr>
-            <a:r>
-              <a:rPr lang="en-US" sz="1050" dirty="0">
-                <a:solidFill>
-                  <a:srgbClr val="2D3748"/>
-                </a:solidFill>
-                <a:latin typeface="Consolas" pitchFamily="34" charset="0"/>
-                <a:ea typeface="Consolas" pitchFamily="34" charset="-122"/>
-                <a:cs typeface="Consolas" pitchFamily="34" charset="-120"/>
-              </a:rPr>
-              <a:t>machine[j,t]=m /\ machine[k,t]=m -&gt; no_overlap(...)</a:t>
-            </a:r>
-            <a:endParaRPr lang="en-US" sz="1050" dirty="0"/>
-          </a:p>
-        </p:txBody>
-      </p:sp>
-      <p:sp>
-        <p:nvSpPr>
           <p:cNvPr id="23" name="Shape 21"/>
           <p:cNvSpPr/>
           <p:nvPr/>
@@ -22339,45 +22066,6 @@
               <a:t>solve minimize makespan: </a:t>
             </a:r>
             <a:endParaRPr lang="en-US" sz="1150" dirty="0"/>
-          </a:p>
-        </p:txBody>
-      </p:sp>
-      <p:sp>
-        <p:nvSpPr>
-          <p:cNvPr id="27" name="Text 25"/>
-          <p:cNvSpPr/>
-          <p:nvPr/>
-        </p:nvSpPr>
-        <p:spPr>
-          <a:xfrm>
-            <a:off x="3931920" y="3730752"/>
-            <a:ext cx="4754880" cy="420624"/>
-          </a:xfrm>
-          <a:prstGeom prst="rect">
-            <a:avLst/>
-          </a:prstGeom>
-          <a:noFill/>
-          <a:ln/>
-        </p:spPr>
-        <p:txBody>
-          <a:bodyPr wrap="square" rtlCol="0" anchor="ctr"/>
-          <a:lstStyle/>
-          <a:p>
-            <a:pPr marL="0" indent="0">
-              <a:buNone/>
-            </a:pPr>
-            <a:r>
-              <a:rPr lang="en-US" sz="1050" dirty="0">
-                <a:solidFill>
-                  <a:srgbClr val="2D3748"/>
-                </a:solidFill>
-                <a:latin typeface="Consolas" pitchFamily="34" charset="0"/>
-                <a:ea typeface="Consolas" pitchFamily="34" charset="-122"/>
-                <a:cs typeface="Consolas" pitchFamily="34" charset="-120"/>
-              </a:rPr>
-              <a:t>เปลี่ยน solve satisfy → solve minimize makespan; แล้วรัน</a:t>
-            </a:r>
-            <a:endParaRPr lang="en-US" sz="1050" dirty="0"/>
           </a:p>
         </p:txBody>
       </p:sp>

</xml_diff>